<commit_message>
Document command behavior and add real Gazebo RViz captures
</commit_message>
<xml_diff>
--- a/blocks/A_ros2_basics/Block_A_실습결과_명령어.pptx
+++ b/blocks/A_ros2_basics/Block_A_실습결과_명령어.pptx
@@ -10,6 +10,7 @@
     <p:sldId id="258" r:id="rId9"/>
     <p:sldId id="259" r:id="rId10"/>
     <p:sldId id="260" r:id="rId11"/>
+    <p:sldId id="261" r:id="rId12"/>
   </p:sldIdLst>
   <p:sldSz cx="12191695" cy="6858000" type="screen4x3"/>
   <p:notesSz cx="6858000" cy="9144000"/>
@@ -4170,6 +4171,333 @@
               </a:defRPr>
             </a:pPr>
             <a:r>
+              <a:t>명령어 동작과 설정 포인트</a:t>
+            </a:r>
+          </a:p>
+        </p:txBody>
+      </p:sp>
+      <p:sp>
+        <p:nvSpPr>
+          <p:cNvPr id="5" name="TextBox 4"/>
+          <p:cNvSpPr txBox="1"/>
+          <p:nvPr/>
+        </p:nvSpPr>
+        <p:spPr>
+          <a:xfrm>
+            <a:off x="411480" y="6556248"/>
+            <a:ext cx="11247120" cy="164592"/>
+          </a:xfrm>
+          <a:prstGeom prst="rect">
+            <a:avLst/>
+          </a:prstGeom>
+          <a:noFill/>
+        </p:spPr>
+        <p:txBody>
+          <a:bodyPr wrap="square" anchor="t">
+            <a:spAutoFit/>
+          </a:bodyPr>
+          <a:lstStyle/>
+          <a:p>
+            <a:pPr>
+              <a:spcAft>
+                <a:spcPts val="500"/>
+              </a:spcAft>
+              <a:defRPr sz="1000" b="0">
+                <a:solidFill>
+                  <a:srgbClr val="667080"/>
+                </a:solidFill>
+                <a:latin typeface="Noto Sans CJK KR"/>
+              </a:defRPr>
+            </a:pPr>
+            <a:r>
+              <a:t>ROS 2 + Gazebo AGV 실습 · 모든 텍스트 최소 10pt</a:t>
+            </a:r>
+          </a:p>
+        </p:txBody>
+      </p:sp>
+      <p:sp>
+        <p:nvSpPr>
+          <p:cNvPr id="6" name="TextBox 5"/>
+          <p:cNvSpPr txBox="1"/>
+          <p:nvPr/>
+        </p:nvSpPr>
+        <p:spPr>
+          <a:xfrm>
+            <a:off x="594360" y="960120"/>
+            <a:ext cx="10972800" cy="411480"/>
+          </a:xfrm>
+          <a:prstGeom prst="rect">
+            <a:avLst/>
+          </a:prstGeom>
+          <a:noFill/>
+        </p:spPr>
+        <p:txBody>
+          <a:bodyPr wrap="square" anchor="t">
+            <a:spAutoFit/>
+          </a:bodyPr>
+          <a:lstStyle/>
+          <a:p>
+            <a:pPr>
+              <a:spcAft>
+                <a:spcPts val="500"/>
+              </a:spcAft>
+              <a:defRPr sz="2100" b="1">
+                <a:solidFill>
+                  <a:srgbClr val="173E6F"/>
+                </a:solidFill>
+                <a:latin typeface="Noto Sans CJK KR"/>
+              </a:defRPr>
+            </a:pPr>
+            <a:r>
+              <a:t>이 명령이 실제로 하는 일</a:t>
+            </a:r>
+          </a:p>
+        </p:txBody>
+      </p:sp>
+      <p:sp>
+        <p:nvSpPr>
+          <p:cNvPr id="7" name="TextBox 6"/>
+          <p:cNvSpPr txBox="1"/>
+          <p:nvPr/>
+        </p:nvSpPr>
+        <p:spPr>
+          <a:xfrm>
+            <a:off x="731520" y="1508760"/>
+            <a:ext cx="10698480" cy="4480560"/>
+          </a:xfrm>
+          <a:prstGeom prst="rect">
+            <a:avLst/>
+          </a:prstGeom>
+          <a:noFill/>
+        </p:spPr>
+        <p:txBody>
+          <a:bodyPr wrap="square" anchor="t">
+            <a:spAutoFit/>
+          </a:bodyPr>
+          <a:lstStyle/>
+          <a:p>
+            <a:pPr>
+              <a:spcAft>
+                <a:spcPts val="500"/>
+              </a:spcAft>
+              <a:defRPr sz="1500" b="0">
+                <a:solidFill>
+                  <a:srgbClr val="212B3D"/>
+                </a:solidFill>
+                <a:latin typeface="Noto Sans CJK KR"/>
+              </a:defRPr>
+            </a:pPr>
+            <a:r>
+              <a:t>• source: 현재 터미널에 ROS 2 Jazzy와 workspace overlay를 등록한다.</a:t>
+            </a:r>
+          </a:p>
+          <a:p>
+            <a:pPr>
+              <a:spcAft>
+                <a:spcPts val="500"/>
+              </a:spcAft>
+              <a:defRPr sz="1500" b="0">
+                <a:solidFill>
+                  <a:srgbClr val="212B3D"/>
+                </a:solidFill>
+                <a:latin typeface="Noto Sans CJK KR"/>
+              </a:defRPr>
+            </a:pPr>
+            <a:r>
+              <a:t>• ros2 run: setup.py에 등록된 console script를 찾아 독립 노드로 실행한다.</a:t>
+            </a:r>
+          </a:p>
+          <a:p>
+            <a:pPr>
+              <a:spcAft>
+                <a:spcPts val="500"/>
+              </a:spcAft>
+              <a:defRPr sz="1500" b="0">
+                <a:solidFill>
+                  <a:srgbClr val="212B3D"/>
+                </a:solidFill>
+                <a:latin typeface="Noto Sans CJK KR"/>
+              </a:defRPr>
+            </a:pPr>
+            <a:r>
+              <a:t>• counter_publisher는 1초 timer·queue depth 10으로 /counter를 발행하며, 속도 명령은 -p linear_speed:=값으로 조절한다.</a:t>
+            </a:r>
+          </a:p>
+        </p:txBody>
+      </p:sp>
+      <p:sp>
+        <p:nvSpPr>
+          <p:cNvPr id="8" name="TextBox 7"/>
+          <p:cNvSpPr txBox="1"/>
+          <p:nvPr/>
+        </p:nvSpPr>
+        <p:spPr>
+          <a:xfrm>
+            <a:off x="731520" y="5440680"/>
+            <a:ext cx="10698480" cy="502920"/>
+          </a:xfrm>
+          <a:prstGeom prst="rect">
+            <a:avLst/>
+          </a:prstGeom>
+          <a:noFill/>
+        </p:spPr>
+        <p:txBody>
+          <a:bodyPr wrap="square" anchor="t">
+            <a:spAutoFit/>
+          </a:bodyPr>
+          <a:lstStyle/>
+          <a:p>
+            <a:pPr>
+              <a:spcAft>
+                <a:spcPts val="500"/>
+              </a:spcAft>
+              <a:defRPr sz="1200" b="0">
+                <a:solidFill>
+                  <a:srgbClr val="3F5373"/>
+                </a:solidFill>
+                <a:latin typeface="Noto Sans CJK KR"/>
+              </a:defRPr>
+            </a:pPr>
+            <a:r>
+              <a:t>수치·토픽·방향을 바꿀 때는 해당 Block의 Mxx README에서 구현 파일과 기대 결과를 함께 확인합니다.</a:t>
+            </a:r>
+          </a:p>
+        </p:txBody>
+      </p:sp>
+    </p:spTree>
+  </p:cSld>
+  <p:clrMapOvr>
+    <a:masterClrMapping/>
+  </p:clrMapOvr>
+</p:sld>
+</file>
+
+<file path=ppt/slides/slide5.xml><?xml version="1.0" encoding="utf-8"?>
+<p:sld xmlns:a="http://schemas.openxmlformats.org/drawingml/2006/main" xmlns:p="http://schemas.openxmlformats.org/presentationml/2006/main" xmlns:r="http://schemas.openxmlformats.org/officeDocument/2006/relationships">
+  <p:cSld>
+    <p:spTree>
+      <p:nvGrpSpPr>
+        <p:cNvPr id="1" name=""/>
+        <p:cNvGrpSpPr/>
+        <p:nvPr/>
+      </p:nvGrpSpPr>
+      <p:grpSpPr/>
+      <p:sp>
+        <p:nvSpPr>
+          <p:cNvPr id="2" name="Rectangle 1"/>
+          <p:cNvSpPr/>
+          <p:nvPr/>
+        </p:nvSpPr>
+        <p:spPr>
+          <a:xfrm>
+            <a:off x="0" y="0"/>
+            <a:ext cx="12191695" cy="749808"/>
+          </a:xfrm>
+          <a:prstGeom prst="rect">
+            <a:avLst/>
+          </a:prstGeom>
+          <a:solidFill>
+            <a:srgbClr val="173E6F"/>
+          </a:solidFill>
+          <a:ln>
+            <a:noFill/>
+          </a:ln>
+        </p:spPr>
+        <p:style>
+          <a:lnRef idx="1">
+            <a:schemeClr val="accent1"/>
+          </a:lnRef>
+          <a:fillRef idx="3">
+            <a:schemeClr val="accent1"/>
+          </a:fillRef>
+          <a:effectRef idx="2">
+            <a:schemeClr val="accent1"/>
+          </a:effectRef>
+          <a:fontRef idx="minor">
+            <a:schemeClr val="lt1"/>
+          </a:fontRef>
+        </p:style>
+        <p:txBody>
+          <a:bodyPr rtlCol="0" anchor="ctr"/>
+          <a:lstStyle/>
+          <a:p>
+            <a:pPr algn="ctr"/>
+          </a:p>
+        </p:txBody>
+      </p:sp>
+      <p:sp>
+        <p:nvSpPr>
+          <p:cNvPr id="3" name="TextBox 2"/>
+          <p:cNvSpPr txBox="1"/>
+          <p:nvPr/>
+        </p:nvSpPr>
+        <p:spPr>
+          <a:xfrm>
+            <a:off x="411480" y="137160"/>
+            <a:ext cx="8046720" cy="320040"/>
+          </a:xfrm>
+          <a:prstGeom prst="rect">
+            <a:avLst/>
+          </a:prstGeom>
+          <a:noFill/>
+        </p:spPr>
+        <p:txBody>
+          <a:bodyPr wrap="square" anchor="t">
+            <a:spAutoFit/>
+          </a:bodyPr>
+          <a:lstStyle/>
+          <a:p>
+            <a:pPr>
+              <a:spcAft>
+                <a:spcPts val="500"/>
+              </a:spcAft>
+              <a:defRPr sz="2500" b="1">
+                <a:solidFill>
+                  <a:srgbClr val="FFFFFF"/>
+                </a:solidFill>
+                <a:latin typeface="Noto Sans CJK KR"/>
+              </a:defRPr>
+            </a:pPr>
+            <a:r>
+              <a:t>Block A — ROS 2 기초</a:t>
+            </a:r>
+          </a:p>
+        </p:txBody>
+      </p:sp>
+      <p:sp>
+        <p:nvSpPr>
+          <p:cNvPr id="4" name="TextBox 3"/>
+          <p:cNvSpPr txBox="1"/>
+          <p:nvPr/>
+        </p:nvSpPr>
+        <p:spPr>
+          <a:xfrm>
+            <a:off x="8321040" y="182880"/>
+            <a:ext cx="3474720" cy="256032"/>
+          </a:xfrm>
+          <a:prstGeom prst="rect">
+            <a:avLst/>
+          </a:prstGeom>
+          <a:noFill/>
+        </p:spPr>
+        <p:txBody>
+          <a:bodyPr wrap="square" anchor="t">
+            <a:spAutoFit/>
+          </a:bodyPr>
+          <a:lstStyle/>
+          <a:p>
+            <a:pPr>
+              <a:spcAft>
+                <a:spcPts val="500"/>
+              </a:spcAft>
+              <a:defRPr sz="1000" b="0">
+                <a:solidFill>
+                  <a:srgbClr val="DCEAFC"/>
+                </a:solidFill>
+                <a:latin typeface="Noto Sans CJK KR"/>
+              </a:defRPr>
+            </a:pPr>
+            <a:r>
               <a:t>실제 실행 결과</a:t>
             </a:r>
           </a:p>
@@ -4246,7 +4574,7 @@
 </p:sld>
 </file>
 
-<file path=ppt/slides/slide5.xml><?xml version="1.0" encoding="utf-8"?>
+<file path=ppt/slides/slide6.xml><?xml version="1.0" encoding="utf-8"?>
 <p:sld xmlns:a="http://schemas.openxmlformats.org/drawingml/2006/main" xmlns:p="http://schemas.openxmlformats.org/presentationml/2006/main" xmlns:r="http://schemas.openxmlformats.org/officeDocument/2006/relationships">
   <p:cSld>
     <p:spTree>

</xml_diff>

<commit_message>
Turn block presentations into beginner file creation lessons
</commit_message>
<xml_diff>
--- a/blocks/A_ros2_basics/Block_A_실습결과_명령어.pptx
+++ b/blocks/A_ros2_basics/Block_A_실습결과_명령어.pptx
@@ -11,6 +11,8 @@
     <p:sldId id="259" r:id="rId10"/>
     <p:sldId id="260" r:id="rId11"/>
     <p:sldId id="261" r:id="rId12"/>
+    <p:sldId id="262" r:id="rId13"/>
+    <p:sldId id="263" r:id="rId14"/>
   </p:sldIdLst>
   <p:sldSz cx="12191695" cy="6858000" type="screen4x3"/>
   <p:notesSz cx="6858000" cy="9144000"/>
@@ -3217,7 +3219,7 @@
               </a:defRPr>
             </a:pPr>
             <a:r>
-              <a:t>M01 ROS 2 개념 · M02 Workspace · M03 Pub/Sub · M04 TF2</a:t>
+              <a:t>M01 ROS 2 개념 · M02 Python/C++ Workspace · M03 Pub/Sub · M04 TF2</a:t>
             </a:r>
           </a:p>
         </p:txBody>
@@ -3583,6 +3585,38 @@
               </a:defRPr>
             </a:pPr>
             <a:r>
+              <a:t>• agv_cpp_examples/src/status_publisher.cpp</a:t>
+            </a:r>
+          </a:p>
+          <a:p>
+            <a:pPr>
+              <a:spcAft>
+                <a:spcPts val="500"/>
+              </a:spcAft>
+              <a:defRPr sz="1500" b="0">
+                <a:solidFill>
+                  <a:srgbClr val="212B3D"/>
+                </a:solidFill>
+                <a:latin typeface="Noto Sans CJK KR"/>
+              </a:defRPr>
+            </a:pPr>
+            <a:r>
+              <a:t>• agv_cpp_examples/CMakeLists.txt</a:t>
+            </a:r>
+          </a:p>
+          <a:p>
+            <a:pPr>
+              <a:spcAft>
+                <a:spcPts val="500"/>
+              </a:spcAft>
+              <a:defRPr sz="1500" b="0">
+                <a:solidFill>
+                  <a:srgbClr val="212B3D"/>
+                </a:solidFill>
+                <a:latin typeface="Noto Sans CJK KR"/>
+              </a:defRPr>
+            </a:pPr>
+            <a:r>
               <a:t>• agv_description/urdf/agv.urdf.xacro</a:t>
             </a:r>
           </a:p>
@@ -3777,7 +3811,7 @@
               </a:defRPr>
             </a:pPr>
             <a:r>
-              <a:t>명령어 실행 순서</a:t>
+              <a:t>초심자 파일 제작 실습 1/2</a:t>
             </a:r>
           </a:p>
         </p:txBody>
@@ -3829,8 +3863,8 @@
         </p:nvSpPr>
         <p:spPr>
           <a:xfrm>
-            <a:off x="594360" y="932688"/>
-            <a:ext cx="10972800" cy="320040"/>
+            <a:off x="502920" y="841248"/>
+            <a:ext cx="11064240" cy="274320"/>
           </a:xfrm>
           <a:prstGeom prst="rect">
             <a:avLst/>
@@ -3847,7 +3881,7 @@
               <a:spcAft>
                 <a:spcPts val="500"/>
               </a:spcAft>
-              <a:defRPr sz="2100" b="1">
+              <a:defRPr sz="1900" b="1">
                 <a:solidFill>
                   <a:srgbClr val="173E6F"/>
                 </a:solidFill>
@@ -3855,21 +3889,99 @@
               </a:defRPr>
             </a:pPr>
             <a:r>
-              <a:t>권장 실행 순서</a:t>
-            </a:r>
-          </a:p>
-        </p:txBody>
-      </p:sp>
-      <p:sp>
-        <p:nvSpPr>
-          <p:cNvPr id="7" name="Rounded Rectangle 6"/>
+              <a:t>Python 노드 파일 만들기 (.py)</a:t>
+            </a:r>
+          </a:p>
+        </p:txBody>
+      </p:sp>
+      <p:sp>
+        <p:nvSpPr>
+          <p:cNvPr id="7" name="TextBox 6"/>
+          <p:cNvSpPr txBox="1"/>
+          <p:nvPr/>
+        </p:nvSpPr>
+        <p:spPr>
+          <a:xfrm>
+            <a:off x="530352" y="1161288"/>
+            <a:ext cx="10972800" cy="201168"/>
+          </a:xfrm>
+          <a:prstGeom prst="rect">
+            <a:avLst/>
+          </a:prstGeom>
+          <a:noFill/>
+        </p:spPr>
+        <p:txBody>
+          <a:bodyPr wrap="square" anchor="t">
+            <a:spAutoFit/>
+          </a:bodyPr>
+          <a:lstStyle/>
+          <a:p>
+            <a:pPr>
+              <a:spcAft>
+                <a:spcPts val="500"/>
+              </a:spcAft>
+              <a:defRPr sz="1100" b="0">
+                <a:solidFill>
+                  <a:srgbClr val="4C5B74"/>
+                </a:solidFill>
+                <a:latin typeface="Noto Sans CJK KR"/>
+              </a:defRPr>
+            </a:pPr>
+            <a:r>
+              <a:t>실제 파일: agv_ws/src/agv_control/agv_control/counter_publisher.py + setup.py</a:t>
+            </a:r>
+          </a:p>
+        </p:txBody>
+      </p:sp>
+      <p:sp>
+        <p:nvSpPr>
+          <p:cNvPr id="8" name="TextBox 7"/>
+          <p:cNvSpPr txBox="1"/>
+          <p:nvPr/>
+        </p:nvSpPr>
+        <p:spPr>
+          <a:xfrm>
+            <a:off x="530352" y="1362456"/>
+            <a:ext cx="10972800" cy="182880"/>
+          </a:xfrm>
+          <a:prstGeom prst="rect">
+            <a:avLst/>
+          </a:prstGeom>
+          <a:noFill/>
+        </p:spPr>
+        <p:txBody>
+          <a:bodyPr wrap="square" anchor="t">
+            <a:spAutoFit/>
+          </a:bodyPr>
+          <a:lstStyle/>
+          <a:p>
+            <a:pPr>
+              <a:spcAft>
+                <a:spcPts val="500"/>
+              </a:spcAft>
+              <a:defRPr sz="1000" b="0">
+                <a:solidFill>
+                  <a:srgbClr val="17638C"/>
+                </a:solidFill>
+                <a:latin typeface="Noto Sans CJK KR"/>
+              </a:defRPr>
+            </a:pPr>
+            <a:r>
+              <a:t>처음 만들 때: ros2 pkg create --build-type ament_python learning_py --dependencies rclpy std_msgs</a:t>
+            </a:r>
+          </a:p>
+        </p:txBody>
+      </p:sp>
+      <p:sp>
+        <p:nvSpPr>
+          <p:cNvPr id="9" name="Rounded Rectangle 8"/>
           <p:cNvSpPr/>
           <p:nvPr/>
         </p:nvSpPr>
         <p:spPr>
           <a:xfrm>
-            <a:off x="594360" y="1417320"/>
-            <a:ext cx="10972800" cy="4526280"/>
+            <a:off x="502920" y="1627632"/>
+            <a:ext cx="5806440" cy="4416552"/>
           </a:xfrm>
           <a:prstGeom prst="roundRect">
             <a:avLst/>
@@ -3898,14 +4010,14 @@
           </a:fontRef>
         </p:style>
         <p:txBody>
-          <a:bodyPr rtlCol="0" anchor="ctr" lIns="237744" tIns="182880"/>
+          <a:bodyPr rtlCol="0" anchor="ctr" lIns="182880" tIns="137160"/>
           <a:lstStyle/>
           <a:p>
             <a:pPr algn="ctr">
               <a:spcAft>
-                <a:spcPts val="700"/>
-              </a:spcAft>
-              <a:defRPr sz="1100">
+                <a:spcPts val="300"/>
+              </a:spcAft>
+              <a:defRPr sz="1000">
                 <a:solidFill>
                   <a:srgbClr val="DFEDFF"/>
                 </a:solidFill>
@@ -3913,15 +4025,15 @@
               </a:defRPr>
             </a:pPr>
             <a:r>
-              <a:t>source /opt/ros/jazzy/setup.bash</a:t>
-            </a:r>
-          </a:p>
-          <a:p>
-            <a:pPr>
-              <a:spcAft>
-                <a:spcPts val="700"/>
-              </a:spcAft>
-              <a:defRPr sz="1100">
+              <a:t>self.publisher = self.create_publisher(Int32, '/counter', 10)</a:t>
+            </a:r>
+          </a:p>
+          <a:p>
+            <a:pPr>
+              <a:spcAft>
+                <a:spcPts val="300"/>
+              </a:spcAft>
+              <a:defRPr sz="1000">
                 <a:solidFill>
                   <a:srgbClr val="DFEDFF"/>
                 </a:solidFill>
@@ -3929,15 +4041,15 @@
               </a:defRPr>
             </a:pPr>
             <a:r>
-              <a:t>cd /home/lab4090/ros2_curri/agv_ws</a:t>
-            </a:r>
-          </a:p>
-          <a:p>
-            <a:pPr>
-              <a:spcAft>
-                <a:spcPts val="700"/>
-              </a:spcAft>
-              <a:defRPr sz="1100">
+              <a:t>self.value = 0</a:t>
+            </a:r>
+          </a:p>
+          <a:p>
+            <a:pPr>
+              <a:spcAft>
+                <a:spcPts val="300"/>
+              </a:spcAft>
+              <a:defRPr sz="1000">
                 <a:solidFill>
                   <a:srgbClr val="DFEDFF"/>
                 </a:solidFill>
@@ -3945,31 +4057,28 @@
               </a:defRPr>
             </a:pPr>
             <a:r>
-              <a:t>colcon build --symlink-install --packages-select agv_control agv_description</a:t>
-            </a:r>
-          </a:p>
-          <a:p>
-            <a:pPr>
-              <a:spcAft>
-                <a:spcPts val="700"/>
-              </a:spcAft>
-              <a:defRPr sz="1100">
+              <a:t>self.create_timer(1.0, self.publish_counter)</a:t>
+            </a:r>
+          </a:p>
+          <a:p>
+            <a:pPr>
+              <a:spcAft>
+                <a:spcPts val="300"/>
+              </a:spcAft>
+              <a:defRPr sz="1000">
                 <a:solidFill>
                   <a:srgbClr val="DFEDFF"/>
                 </a:solidFill>
                 <a:latin typeface="Noto Sans CJK KR"/>
               </a:defRPr>
             </a:pPr>
-            <a:r>
-              <a:t>source install/setup.bash</a:t>
-            </a:r>
-          </a:p>
-          <a:p>
-            <a:pPr>
-              <a:spcAft>
-                <a:spcPts val="700"/>
-              </a:spcAft>
-              <a:defRPr sz="1100">
+          </a:p>
+          <a:p>
+            <a:pPr>
+              <a:spcAft>
+                <a:spcPts val="300"/>
+              </a:spcAft>
+              <a:defRPr sz="1000">
                 <a:solidFill>
                   <a:srgbClr val="DFEDFF"/>
                 </a:solidFill>
@@ -3977,15 +4086,15 @@
               </a:defRPr>
             </a:pPr>
             <a:r>
-              <a:t>ros2 run agv_control counter_publisher</a:t>
-            </a:r>
-          </a:p>
-          <a:p>
-            <a:pPr>
-              <a:spcAft>
-                <a:spcPts val="700"/>
-              </a:spcAft>
-              <a:defRPr sz="1100">
+              <a:t>def publish_counter(self):</a:t>
+            </a:r>
+          </a:p>
+          <a:p>
+            <a:pPr>
+              <a:spcAft>
+                <a:spcPts val="300"/>
+              </a:spcAft>
+              <a:defRPr sz="1000">
                 <a:solidFill>
                   <a:srgbClr val="DFEDFF"/>
                 </a:solidFill>
@@ -3993,21 +4102,98 @@
               </a:defRPr>
             </a:pPr>
             <a:r>
-              <a:t># 새 터미널: ros2 run agv_control counter_monitor</a:t>
-            </a:r>
-          </a:p>
-        </p:txBody>
-      </p:sp>
-      <p:sp>
-        <p:nvSpPr>
-          <p:cNvPr id="8" name="TextBox 7"/>
+              <a:t>    message = Int32(data=self.value)</a:t>
+            </a:r>
+          </a:p>
+          <a:p>
+            <a:pPr>
+              <a:spcAft>
+                <a:spcPts val="300"/>
+              </a:spcAft>
+              <a:defRPr sz="1000">
+                <a:solidFill>
+                  <a:srgbClr val="DFEDFF"/>
+                </a:solidFill>
+                <a:latin typeface="Noto Sans CJK KR"/>
+              </a:defRPr>
+            </a:pPr>
+            <a:r>
+              <a:t>    self.publisher.publish(message)</a:t>
+            </a:r>
+          </a:p>
+          <a:p>
+            <a:pPr>
+              <a:spcAft>
+                <a:spcPts val="300"/>
+              </a:spcAft>
+              <a:defRPr sz="1000">
+                <a:solidFill>
+                  <a:srgbClr val="DFEDFF"/>
+                </a:solidFill>
+                <a:latin typeface="Noto Sans CJK KR"/>
+              </a:defRPr>
+            </a:pPr>
+            <a:r>
+              <a:t>    self.value += 1</a:t>
+            </a:r>
+          </a:p>
+          <a:p>
+            <a:pPr>
+              <a:spcAft>
+                <a:spcPts val="300"/>
+              </a:spcAft>
+              <a:defRPr sz="1000">
+                <a:solidFill>
+                  <a:srgbClr val="DFEDFF"/>
+                </a:solidFill>
+                <a:latin typeface="Noto Sans CJK KR"/>
+              </a:defRPr>
+            </a:pPr>
+          </a:p>
+          <a:p>
+            <a:pPr>
+              <a:spcAft>
+                <a:spcPts val="300"/>
+              </a:spcAft>
+              <a:defRPr sz="1000">
+                <a:solidFill>
+                  <a:srgbClr val="DFEDFF"/>
+                </a:solidFill>
+                <a:latin typeface="Noto Sans CJK KR"/>
+              </a:defRPr>
+            </a:pPr>
+            <a:r>
+              <a:t># setup.py</a:t>
+            </a:r>
+          </a:p>
+          <a:p>
+            <a:pPr>
+              <a:spcAft>
+                <a:spcPts val="300"/>
+              </a:spcAft>
+              <a:defRPr sz="1000">
+                <a:solidFill>
+                  <a:srgbClr val="DFEDFF"/>
+                </a:solidFill>
+                <a:latin typeface="Noto Sans CJK KR"/>
+              </a:defRPr>
+            </a:pPr>
+            <a:r>
+              <a:t>'counter_publisher = agv_control.counter_publisher:main'</a:t>
+            </a:r>
+          </a:p>
+        </p:txBody>
+      </p:sp>
+      <p:sp>
+        <p:nvSpPr>
+          <p:cNvPr id="10" name="TextBox 9"/>
           <p:cNvSpPr txBox="1"/>
           <p:nvPr/>
         </p:nvSpPr>
         <p:spPr>
           <a:xfrm>
-            <a:off x="685800" y="6089904"/>
-            <a:ext cx="10789920" cy="256032"/>
+            <a:off x="6537960" y="1627632"/>
+            <a:ext cx="4892040" cy="320040"/>
           </a:xfrm>
           <a:prstGeom prst="rect">
             <a:avLst/>
@@ -4024,15 +4210,164 @@
               <a:spcAft>
                 <a:spcPts val="500"/>
               </a:spcAft>
-              <a:defRPr sz="1000" b="0">
-                <a:solidFill>
-                  <a:srgbClr val="505C70"/>
-                </a:solidFill>
-                <a:latin typeface="Noto Sans CJK KR"/>
-              </a:defRPr>
-            </a:pPr>
-            <a:r>
-              <a:t>명령은 Block README의 순서와 동일합니다. 새 터미널에서도 ROS와 workspace를 source해야 합니다.</a:t>
+              <a:defRPr sz="1600" b="1">
+                <a:solidFill>
+                  <a:srgbClr val="173E6F"/>
+                </a:solidFill>
+                <a:latin typeface="Noto Sans CJK KR"/>
+              </a:defRPr>
+            </a:pPr>
+            <a:r>
+              <a:t>만드는 순서</a:t>
+            </a:r>
+          </a:p>
+        </p:txBody>
+      </p:sp>
+      <p:sp>
+        <p:nvSpPr>
+          <p:cNvPr id="11" name="TextBox 10"/>
+          <p:cNvSpPr txBox="1"/>
+          <p:nvPr/>
+        </p:nvSpPr>
+        <p:spPr>
+          <a:xfrm>
+            <a:off x="6565392" y="1975104"/>
+            <a:ext cx="4800600" cy="2258568"/>
+          </a:xfrm>
+          <a:prstGeom prst="rect">
+            <a:avLst/>
+          </a:prstGeom>
+          <a:noFill/>
+        </p:spPr>
+        <p:txBody>
+          <a:bodyPr wrap="square" anchor="t">
+            <a:spAutoFit/>
+          </a:bodyPr>
+          <a:lstStyle/>
+          <a:p>
+            <a:pPr>
+              <a:spcAft>
+                <a:spcPts val="500"/>
+              </a:spcAft>
+              <a:defRPr sz="1200" b="0">
+                <a:solidFill>
+                  <a:srgbClr val="212B3D"/>
+                </a:solidFill>
+                <a:latin typeface="Noto Sans CJK KR"/>
+              </a:defRPr>
+            </a:pPr>
+            <a:r>
+              <a:t>• 1. ament_python 패키지를 만들고 agv_control/agv_control/에 .py 파일을 둡니다.</a:t>
+            </a:r>
+          </a:p>
+          <a:p>
+            <a:pPr>
+              <a:spcAft>
+                <a:spcPts val="500"/>
+              </a:spcAft>
+              <a:defRPr sz="1200" b="0">
+                <a:solidFill>
+                  <a:srgbClr val="212B3D"/>
+                </a:solidFill>
+                <a:latin typeface="Noto Sans CJK KR"/>
+              </a:defRPr>
+            </a:pPr>
+            <a:r>
+              <a:t>• 2. Node·publisher·timer를 작성한 뒤 setup.py의 console_scripts에 실행 이름을 등록합니다.</a:t>
+            </a:r>
+          </a:p>
+          <a:p>
+            <a:pPr>
+              <a:spcAft>
+                <a:spcPts val="500"/>
+              </a:spcAft>
+              <a:defRPr sz="1200" b="0">
+                <a:solidFill>
+                  <a:srgbClr val="212B3D"/>
+                </a:solidFill>
+                <a:latin typeface="Noto Sans CJK KR"/>
+              </a:defRPr>
+            </a:pPr>
+            <a:r>
+              <a:t>• 3. build → source → ros2 run 순서로 실행합니다. source가 없으면 새 실행 이름을 찾지 못합니다.</a:t>
+            </a:r>
+          </a:p>
+        </p:txBody>
+      </p:sp>
+      <p:sp>
+        <p:nvSpPr>
+          <p:cNvPr id="12" name="TextBox 11"/>
+          <p:cNvSpPr txBox="1"/>
+          <p:nvPr/>
+        </p:nvSpPr>
+        <p:spPr>
+          <a:xfrm>
+            <a:off x="6565392" y="4480560"/>
+            <a:ext cx="4800600" cy="320040"/>
+          </a:xfrm>
+          <a:prstGeom prst="rect">
+            <a:avLst/>
+          </a:prstGeom>
+          <a:noFill/>
+        </p:spPr>
+        <p:txBody>
+          <a:bodyPr wrap="square" anchor="t">
+            <a:spAutoFit/>
+          </a:bodyPr>
+          <a:lstStyle/>
+          <a:p>
+            <a:pPr>
+              <a:spcAft>
+                <a:spcPts val="500"/>
+              </a:spcAft>
+              <a:defRPr sz="1600" b="1">
+                <a:solidFill>
+                  <a:srgbClr val="173E6F"/>
+                </a:solidFill>
+                <a:latin typeface="Noto Sans CJK KR"/>
+              </a:defRPr>
+            </a:pPr>
+            <a:r>
+              <a:t>실행하면 이렇게 됩니다</a:t>
+            </a:r>
+          </a:p>
+        </p:txBody>
+      </p:sp>
+      <p:sp>
+        <p:nvSpPr>
+          <p:cNvPr id="13" name="TextBox 12"/>
+          <p:cNvSpPr txBox="1"/>
+          <p:nvPr/>
+        </p:nvSpPr>
+        <p:spPr>
+          <a:xfrm>
+            <a:off x="6565392" y="4892040"/>
+            <a:ext cx="4800600" cy="822960"/>
+          </a:xfrm>
+          <a:prstGeom prst="rect">
+            <a:avLst/>
+          </a:prstGeom>
+          <a:noFill/>
+        </p:spPr>
+        <p:txBody>
+          <a:bodyPr wrap="square" anchor="t">
+            <a:spAutoFit/>
+          </a:bodyPr>
+          <a:lstStyle/>
+          <a:p>
+            <a:pPr>
+              <a:spcAft>
+                <a:spcPts val="500"/>
+              </a:spcAft>
+              <a:defRPr sz="1200" b="0">
+                <a:solidFill>
+                  <a:srgbClr val="212B3D"/>
+                </a:solidFill>
+                <a:latin typeface="Noto Sans CJK KR"/>
+              </a:defRPr>
+            </a:pPr>
+            <a:r>
+              <a:t>실행하면 1초마다 /counter에 0, 1, 2…가 publish되고, counter_monitor가 같은 값을 받습니다.</a:t>
             </a:r>
           </a:p>
         </p:txBody>
@@ -4171,7 +4506,7 @@
               </a:defRPr>
             </a:pPr>
             <a:r>
-              <a:t>명령어 동작과 설정 포인트</a:t>
+              <a:t>초심자 파일 제작 실습 2/2</a:t>
             </a:r>
           </a:p>
         </p:txBody>
@@ -4223,8 +4558,8 @@
         </p:nvSpPr>
         <p:spPr>
           <a:xfrm>
-            <a:off x="594360" y="960120"/>
-            <a:ext cx="10972800" cy="411480"/>
+            <a:off x="502920" y="841248"/>
+            <a:ext cx="11064240" cy="274320"/>
           </a:xfrm>
           <a:prstGeom prst="rect">
             <a:avLst/>
@@ -4241,7 +4576,7 @@
               <a:spcAft>
                 <a:spcPts val="500"/>
               </a:spcAft>
-              <a:defRPr sz="2100" b="1">
+              <a:defRPr sz="1900" b="1">
                 <a:solidFill>
                   <a:srgbClr val="173E6F"/>
                 </a:solidFill>
@@ -4249,7 +4584,7 @@
               </a:defRPr>
             </a:pPr>
             <a:r>
-              <a:t>이 명령이 실제로 하는 일</a:t>
+              <a:t>C++ 노드 파일 만들기 (.cpp)</a:t>
             </a:r>
           </a:p>
         </p:txBody>
@@ -4262,8 +4597,8 @@
         </p:nvSpPr>
         <p:spPr>
           <a:xfrm>
-            <a:off x="731520" y="1508760"/>
-            <a:ext cx="10698480" cy="4480560"/>
+            <a:off x="530352" y="1161288"/>
+            <a:ext cx="10972800" cy="201168"/>
           </a:xfrm>
           <a:prstGeom prst="rect">
             <a:avLst/>
@@ -4280,47 +4615,15 @@
               <a:spcAft>
                 <a:spcPts val="500"/>
               </a:spcAft>
-              <a:defRPr sz="1500" b="0">
-                <a:solidFill>
-                  <a:srgbClr val="212B3D"/>
-                </a:solidFill>
-                <a:latin typeface="Noto Sans CJK KR"/>
-              </a:defRPr>
-            </a:pPr>
-            <a:r>
-              <a:t>• source: 현재 터미널에 ROS 2 Jazzy와 workspace overlay를 등록한다.</a:t>
-            </a:r>
-          </a:p>
-          <a:p>
-            <a:pPr>
-              <a:spcAft>
-                <a:spcPts val="500"/>
-              </a:spcAft>
-              <a:defRPr sz="1500" b="0">
-                <a:solidFill>
-                  <a:srgbClr val="212B3D"/>
-                </a:solidFill>
-                <a:latin typeface="Noto Sans CJK KR"/>
-              </a:defRPr>
-            </a:pPr>
-            <a:r>
-              <a:t>• ros2 run: setup.py에 등록된 console script를 찾아 독립 노드로 실행한다.</a:t>
-            </a:r>
-          </a:p>
-          <a:p>
-            <a:pPr>
-              <a:spcAft>
-                <a:spcPts val="500"/>
-              </a:spcAft>
-              <a:defRPr sz="1500" b="0">
-                <a:solidFill>
-                  <a:srgbClr val="212B3D"/>
-                </a:solidFill>
-                <a:latin typeface="Noto Sans CJK KR"/>
-              </a:defRPr>
-            </a:pPr>
-            <a:r>
-              <a:t>• counter_publisher는 1초 timer·queue depth 10으로 /counter를 발행하며, 속도 명령은 -p linear_speed:=값으로 조절한다.</a:t>
+              <a:defRPr sz="1100" b="0">
+                <a:solidFill>
+                  <a:srgbClr val="4C5B74"/>
+                </a:solidFill>
+                <a:latin typeface="Noto Sans CJK KR"/>
+              </a:defRPr>
+            </a:pPr>
+            <a:r>
+              <a:t>실제 파일: agv_ws/src/agv_cpp_examples/src/status_publisher.cpp + CMakeLists.txt</a:t>
             </a:r>
           </a:p>
         </p:txBody>
@@ -4333,8 +4636,8 @@
         </p:nvSpPr>
         <p:spPr>
           <a:xfrm>
-            <a:off x="731520" y="5440680"/>
-            <a:ext cx="10698480" cy="502920"/>
+            <a:off x="530352" y="1362456"/>
+            <a:ext cx="10972800" cy="182880"/>
           </a:xfrm>
           <a:prstGeom prst="rect">
             <a:avLst/>
@@ -4351,15 +4654,402 @@
               <a:spcAft>
                 <a:spcPts val="500"/>
               </a:spcAft>
+              <a:defRPr sz="1000" b="0">
+                <a:solidFill>
+                  <a:srgbClr val="17638C"/>
+                </a:solidFill>
+                <a:latin typeface="Noto Sans CJK KR"/>
+              </a:defRPr>
+            </a:pPr>
+            <a:r>
+              <a:t>처음 만들 때: ros2 pkg create --build-type ament_cmake learning_cpp --dependencies rclcpp std_msgs</a:t>
+            </a:r>
+          </a:p>
+        </p:txBody>
+      </p:sp>
+      <p:sp>
+        <p:nvSpPr>
+          <p:cNvPr id="9" name="Rounded Rectangle 8"/>
+          <p:cNvSpPr/>
+          <p:nvPr/>
+        </p:nvSpPr>
+        <p:spPr>
+          <a:xfrm>
+            <a:off x="502920" y="1627632"/>
+            <a:ext cx="5806440" cy="4416552"/>
+          </a:xfrm>
+          <a:prstGeom prst="roundRect">
+            <a:avLst/>
+          </a:prstGeom>
+          <a:solidFill>
+            <a:srgbClr val="141C2A"/>
+          </a:solidFill>
+          <a:ln>
+            <a:solidFill>
+              <a:srgbClr val="40506E"/>
+            </a:solidFill>
+          </a:ln>
+        </p:spPr>
+        <p:style>
+          <a:lnRef idx="1">
+            <a:schemeClr val="accent1"/>
+          </a:lnRef>
+          <a:fillRef idx="3">
+            <a:schemeClr val="accent1"/>
+          </a:fillRef>
+          <a:effectRef idx="2">
+            <a:schemeClr val="accent1"/>
+          </a:effectRef>
+          <a:fontRef idx="minor">
+            <a:schemeClr val="lt1"/>
+          </a:fontRef>
+        </p:style>
+        <p:txBody>
+          <a:bodyPr rtlCol="0" anchor="ctr" lIns="182880" tIns="137160"/>
+          <a:lstStyle/>
+          <a:p>
+            <a:pPr algn="ctr">
+              <a:spcAft>
+                <a:spcPts val="300"/>
+              </a:spcAft>
+              <a:defRPr sz="1000">
+                <a:solidFill>
+                  <a:srgbClr val="DFEDFF"/>
+                </a:solidFill>
+                <a:latin typeface="Noto Sans CJK KR"/>
+              </a:defRPr>
+            </a:pPr>
+            <a:r>
+              <a:t>publisher_ = this-&gt;create_publisher&lt;std_msgs::msg::String&gt;(</a:t>
+            </a:r>
+          </a:p>
+          <a:p>
+            <a:pPr>
+              <a:spcAft>
+                <a:spcPts val="300"/>
+              </a:spcAft>
+              <a:defRPr sz="1000">
+                <a:solidFill>
+                  <a:srgbClr val="DFEDFF"/>
+                </a:solidFill>
+                <a:latin typeface="Noto Sans CJK KR"/>
+              </a:defRPr>
+            </a:pPr>
+            <a:r>
+              <a:t>  "/cpp_status", 10);</a:t>
+            </a:r>
+          </a:p>
+          <a:p>
+            <a:pPr>
+              <a:spcAft>
+                <a:spcPts val="300"/>
+              </a:spcAft>
+              <a:defRPr sz="1000">
+                <a:solidFill>
+                  <a:srgbClr val="DFEDFF"/>
+                </a:solidFill>
+                <a:latin typeface="Noto Sans CJK KR"/>
+              </a:defRPr>
+            </a:pPr>
+            <a:r>
+              <a:t>timer_ = this-&gt;create_wall_timer(1s,</a:t>
+            </a:r>
+          </a:p>
+          <a:p>
+            <a:pPr>
+              <a:spcAft>
+                <a:spcPts val="300"/>
+              </a:spcAft>
+              <a:defRPr sz="1000">
+                <a:solidFill>
+                  <a:srgbClr val="DFEDFF"/>
+                </a:solidFill>
+                <a:latin typeface="Noto Sans CJK KR"/>
+              </a:defRPr>
+            </a:pPr>
+            <a:r>
+              <a:t>  std::bind(&amp;StatusPublisher::publish_status, this));</a:t>
+            </a:r>
+          </a:p>
+          <a:p>
+            <a:pPr>
+              <a:spcAft>
+                <a:spcPts val="300"/>
+              </a:spcAft>
+              <a:defRPr sz="1000">
+                <a:solidFill>
+                  <a:srgbClr val="DFEDFF"/>
+                </a:solidFill>
+                <a:latin typeface="Noto Sans CJK KR"/>
+              </a:defRPr>
+            </a:pPr>
+          </a:p>
+          <a:p>
+            <a:pPr>
+              <a:spcAft>
+                <a:spcPts val="300"/>
+              </a:spcAft>
+              <a:defRPr sz="1000">
+                <a:solidFill>
+                  <a:srgbClr val="DFEDFF"/>
+                </a:solidFill>
+                <a:latin typeface="Noto Sans CJK KR"/>
+              </a:defRPr>
+            </a:pPr>
+            <a:r>
+              <a:t># CMakeLists.txt</a:t>
+            </a:r>
+          </a:p>
+          <a:p>
+            <a:pPr>
+              <a:spcAft>
+                <a:spcPts val="300"/>
+              </a:spcAft>
+              <a:defRPr sz="1000">
+                <a:solidFill>
+                  <a:srgbClr val="DFEDFF"/>
+                </a:solidFill>
+                <a:latin typeface="Noto Sans CJK KR"/>
+              </a:defRPr>
+            </a:pPr>
+            <a:r>
+              <a:t>add_executable(status_publisher src/status_publisher.cpp)</a:t>
+            </a:r>
+          </a:p>
+          <a:p>
+            <a:pPr>
+              <a:spcAft>
+                <a:spcPts val="300"/>
+              </a:spcAft>
+              <a:defRPr sz="1000">
+                <a:solidFill>
+                  <a:srgbClr val="DFEDFF"/>
+                </a:solidFill>
+                <a:latin typeface="Noto Sans CJK KR"/>
+              </a:defRPr>
+            </a:pPr>
+            <a:r>
+              <a:t>ament_target_dependencies(status_publisher rclcpp std_msgs)</a:t>
+            </a:r>
+          </a:p>
+          <a:p>
+            <a:pPr>
+              <a:spcAft>
+                <a:spcPts val="300"/>
+              </a:spcAft>
+              <a:defRPr sz="1000">
+                <a:solidFill>
+                  <a:srgbClr val="DFEDFF"/>
+                </a:solidFill>
+                <a:latin typeface="Noto Sans CJK KR"/>
+              </a:defRPr>
+            </a:pPr>
+            <a:r>
+              <a:t>install(TARGETS status_publisher</a:t>
+            </a:r>
+          </a:p>
+          <a:p>
+            <a:pPr>
+              <a:spcAft>
+                <a:spcPts val="300"/>
+              </a:spcAft>
+              <a:defRPr sz="1000">
+                <a:solidFill>
+                  <a:srgbClr val="DFEDFF"/>
+                </a:solidFill>
+                <a:latin typeface="Noto Sans CJK KR"/>
+              </a:defRPr>
+            </a:pPr>
+            <a:r>
+              <a:t>  DESTINATION lib/${PROJECT_NAME})</a:t>
+            </a:r>
+          </a:p>
+        </p:txBody>
+      </p:sp>
+      <p:sp>
+        <p:nvSpPr>
+          <p:cNvPr id="10" name="TextBox 9"/>
+          <p:cNvSpPr txBox="1"/>
+          <p:nvPr/>
+        </p:nvSpPr>
+        <p:spPr>
+          <a:xfrm>
+            <a:off x="6537960" y="1627632"/>
+            <a:ext cx="4892040" cy="320040"/>
+          </a:xfrm>
+          <a:prstGeom prst="rect">
+            <a:avLst/>
+          </a:prstGeom>
+          <a:noFill/>
+        </p:spPr>
+        <p:txBody>
+          <a:bodyPr wrap="square" anchor="t">
+            <a:spAutoFit/>
+          </a:bodyPr>
+          <a:lstStyle/>
+          <a:p>
+            <a:pPr>
+              <a:spcAft>
+                <a:spcPts val="500"/>
+              </a:spcAft>
+              <a:defRPr sz="1600" b="1">
+                <a:solidFill>
+                  <a:srgbClr val="173E6F"/>
+                </a:solidFill>
+                <a:latin typeface="Noto Sans CJK KR"/>
+              </a:defRPr>
+            </a:pPr>
+            <a:r>
+              <a:t>만드는 순서</a:t>
+            </a:r>
+          </a:p>
+        </p:txBody>
+      </p:sp>
+      <p:sp>
+        <p:nvSpPr>
+          <p:cNvPr id="11" name="TextBox 10"/>
+          <p:cNvSpPr txBox="1"/>
+          <p:nvPr/>
+        </p:nvSpPr>
+        <p:spPr>
+          <a:xfrm>
+            <a:off x="6565392" y="1975104"/>
+            <a:ext cx="4800600" cy="2258568"/>
+          </a:xfrm>
+          <a:prstGeom prst="rect">
+            <a:avLst/>
+          </a:prstGeom>
+          <a:noFill/>
+        </p:spPr>
+        <p:txBody>
+          <a:bodyPr wrap="square" anchor="t">
+            <a:spAutoFit/>
+          </a:bodyPr>
+          <a:lstStyle/>
+          <a:p>
+            <a:pPr>
+              <a:spcAft>
+                <a:spcPts val="500"/>
+              </a:spcAft>
               <a:defRPr sz="1200" b="0">
                 <a:solidFill>
-                  <a:srgbClr val="3F5373"/>
-                </a:solidFill>
-                <a:latin typeface="Noto Sans CJK KR"/>
-              </a:defRPr>
-            </a:pPr>
-            <a:r>
-              <a:t>수치·토픽·방향을 바꿀 때는 해당 Block의 Mxx README에서 구현 파일과 기대 결과를 함께 확인합니다.</a:t>
+                  <a:srgbClr val="212B3D"/>
+                </a:solidFill>
+                <a:latin typeface="Noto Sans CJK KR"/>
+              </a:defRPr>
+            </a:pPr>
+            <a:r>
+              <a:t>• 1. ros2 pkg create --build-type ament_cmake로 C++ 패키지와 src/ 폴더를 만듭니다.</a:t>
+            </a:r>
+          </a:p>
+          <a:p>
+            <a:pPr>
+              <a:spcAft>
+                <a:spcPts val="500"/>
+              </a:spcAft>
+              <a:defRPr sz="1200" b="0">
+                <a:solidFill>
+                  <a:srgbClr val="212B3D"/>
+                </a:solidFill>
+                <a:latin typeface="Noto Sans CJK KR"/>
+              </a:defRPr>
+            </a:pPr>
+            <a:r>
+              <a:t>• 2. .cpp에서 rclcpp::Node, publisher, timer, spin을 작성합니다.</a:t>
+            </a:r>
+          </a:p>
+          <a:p>
+            <a:pPr>
+              <a:spcAft>
+                <a:spcPts val="500"/>
+              </a:spcAft>
+              <a:defRPr sz="1200" b="0">
+                <a:solidFill>
+                  <a:srgbClr val="212B3D"/>
+                </a:solidFill>
+                <a:latin typeface="Noto Sans CJK KR"/>
+              </a:defRPr>
+            </a:pPr>
+            <a:r>
+              <a:t>• 3. CMakeLists.txt의 add_executable·ament_target_dependencies·install을 모두 작성합니다.</a:t>
+            </a:r>
+          </a:p>
+        </p:txBody>
+      </p:sp>
+      <p:sp>
+        <p:nvSpPr>
+          <p:cNvPr id="12" name="TextBox 11"/>
+          <p:cNvSpPr txBox="1"/>
+          <p:nvPr/>
+        </p:nvSpPr>
+        <p:spPr>
+          <a:xfrm>
+            <a:off x="6565392" y="4480560"/>
+            <a:ext cx="4800600" cy="320040"/>
+          </a:xfrm>
+          <a:prstGeom prst="rect">
+            <a:avLst/>
+          </a:prstGeom>
+          <a:noFill/>
+        </p:spPr>
+        <p:txBody>
+          <a:bodyPr wrap="square" anchor="t">
+            <a:spAutoFit/>
+          </a:bodyPr>
+          <a:lstStyle/>
+          <a:p>
+            <a:pPr>
+              <a:spcAft>
+                <a:spcPts val="500"/>
+              </a:spcAft>
+              <a:defRPr sz="1600" b="1">
+                <a:solidFill>
+                  <a:srgbClr val="173E6F"/>
+                </a:solidFill>
+                <a:latin typeface="Noto Sans CJK KR"/>
+              </a:defRPr>
+            </a:pPr>
+            <a:r>
+              <a:t>실행하면 이렇게 됩니다</a:t>
+            </a:r>
+          </a:p>
+        </p:txBody>
+      </p:sp>
+      <p:sp>
+        <p:nvSpPr>
+          <p:cNvPr id="13" name="TextBox 12"/>
+          <p:cNvSpPr txBox="1"/>
+          <p:nvPr/>
+        </p:nvSpPr>
+        <p:spPr>
+          <a:xfrm>
+            <a:off x="6565392" y="4892040"/>
+            <a:ext cx="4800600" cy="822960"/>
+          </a:xfrm>
+          <a:prstGeom prst="rect">
+            <a:avLst/>
+          </a:prstGeom>
+          <a:noFill/>
+        </p:spPr>
+        <p:txBody>
+          <a:bodyPr wrap="square" anchor="t">
+            <a:spAutoFit/>
+          </a:bodyPr>
+          <a:lstStyle/>
+          <a:p>
+            <a:pPr>
+              <a:spcAft>
+                <a:spcPts val="500"/>
+              </a:spcAft>
+              <a:defRPr sz="1200" b="0">
+                <a:solidFill>
+                  <a:srgbClr val="212B3D"/>
+                </a:solidFill>
+                <a:latin typeface="Noto Sans CJK KR"/>
+              </a:defRPr>
+            </a:pPr>
+            <a:r>
+              <a:t>ros2 run agv_cpp_examples status_publisher 뒤 /cpp_status에 'C++ AGV 상태 정상 #0'이 1초마다 나옵니다.</a:t>
             </a:r>
           </a:p>
         </p:txBody>
@@ -4498,7 +5188,7 @@
               </a:defRPr>
             </a:pPr>
             <a:r>
-              <a:t>실제 실행 결과</a:t>
+              <a:t>명령어 실행 순서</a:t>
             </a:r>
           </a:p>
         </p:txBody>
@@ -4542,30 +5232,238 @@
           </a:p>
         </p:txBody>
       </p:sp>
-      <p:pic>
-        <p:nvPicPr>
-          <p:cNvPr id="6" name="Picture 5" descr="block_a_actual_terminal.png"/>
-          <p:cNvPicPr>
-            <a:picLocks noChangeAspect="1"/>
-          </p:cNvPicPr>
+      <p:sp>
+        <p:nvSpPr>
+          <p:cNvPr id="6" name="TextBox 5"/>
+          <p:cNvSpPr txBox="1"/>
           <p:nvPr/>
-        </p:nvPicPr>
-        <p:blipFill>
-          <a:blip r:embed="rId2"/>
-          <a:stretch>
-            <a:fillRect/>
-          </a:stretch>
-        </p:blipFill>
-        <p:spPr>
-          <a:xfrm>
-            <a:off x="411480" y="932688"/>
-            <a:ext cx="11365992" cy="5422392"/>
+        </p:nvSpPr>
+        <p:spPr>
+          <a:xfrm>
+            <a:off x="594360" y="932688"/>
+            <a:ext cx="10972800" cy="320040"/>
           </a:xfrm>
           <a:prstGeom prst="rect">
             <a:avLst/>
           </a:prstGeom>
-        </p:spPr>
-      </p:pic>
+          <a:noFill/>
+        </p:spPr>
+        <p:txBody>
+          <a:bodyPr wrap="square" anchor="t">
+            <a:spAutoFit/>
+          </a:bodyPr>
+          <a:lstStyle/>
+          <a:p>
+            <a:pPr>
+              <a:spcAft>
+                <a:spcPts val="500"/>
+              </a:spcAft>
+              <a:defRPr sz="2100" b="1">
+                <a:solidFill>
+                  <a:srgbClr val="173E6F"/>
+                </a:solidFill>
+                <a:latin typeface="Noto Sans CJK KR"/>
+              </a:defRPr>
+            </a:pPr>
+            <a:r>
+              <a:t>권장 실행 순서</a:t>
+            </a:r>
+          </a:p>
+        </p:txBody>
+      </p:sp>
+      <p:sp>
+        <p:nvSpPr>
+          <p:cNvPr id="7" name="Rounded Rectangle 6"/>
+          <p:cNvSpPr/>
+          <p:nvPr/>
+        </p:nvSpPr>
+        <p:spPr>
+          <a:xfrm>
+            <a:off x="594360" y="1417320"/>
+            <a:ext cx="10972800" cy="4526280"/>
+          </a:xfrm>
+          <a:prstGeom prst="roundRect">
+            <a:avLst/>
+          </a:prstGeom>
+          <a:solidFill>
+            <a:srgbClr val="141C2A"/>
+          </a:solidFill>
+          <a:ln>
+            <a:solidFill>
+              <a:srgbClr val="40506E"/>
+            </a:solidFill>
+          </a:ln>
+        </p:spPr>
+        <p:style>
+          <a:lnRef idx="1">
+            <a:schemeClr val="accent1"/>
+          </a:lnRef>
+          <a:fillRef idx="3">
+            <a:schemeClr val="accent1"/>
+          </a:fillRef>
+          <a:effectRef idx="2">
+            <a:schemeClr val="accent1"/>
+          </a:effectRef>
+          <a:fontRef idx="minor">
+            <a:schemeClr val="lt1"/>
+          </a:fontRef>
+        </p:style>
+        <p:txBody>
+          <a:bodyPr rtlCol="0" anchor="ctr" lIns="237744" tIns="182880"/>
+          <a:lstStyle/>
+          <a:p>
+            <a:pPr algn="ctr">
+              <a:spcAft>
+                <a:spcPts val="700"/>
+              </a:spcAft>
+              <a:defRPr sz="1100">
+                <a:solidFill>
+                  <a:srgbClr val="DFEDFF"/>
+                </a:solidFill>
+                <a:latin typeface="Noto Sans CJK KR"/>
+              </a:defRPr>
+            </a:pPr>
+            <a:r>
+              <a:t>source /opt/ros/jazzy/setup.bash</a:t>
+            </a:r>
+          </a:p>
+          <a:p>
+            <a:pPr>
+              <a:spcAft>
+                <a:spcPts val="700"/>
+              </a:spcAft>
+              <a:defRPr sz="1100">
+                <a:solidFill>
+                  <a:srgbClr val="DFEDFF"/>
+                </a:solidFill>
+                <a:latin typeface="Noto Sans CJK KR"/>
+              </a:defRPr>
+            </a:pPr>
+            <a:r>
+              <a:t>cd /home/lab4090/ros2_curri/agv_ws</a:t>
+            </a:r>
+          </a:p>
+          <a:p>
+            <a:pPr>
+              <a:spcAft>
+                <a:spcPts val="700"/>
+              </a:spcAft>
+              <a:defRPr sz="1100">
+                <a:solidFill>
+                  <a:srgbClr val="DFEDFF"/>
+                </a:solidFill>
+                <a:latin typeface="Noto Sans CJK KR"/>
+              </a:defRPr>
+            </a:pPr>
+            <a:r>
+              <a:t>colcon build --symlink-install --packages-select agv_control agv_description agv_cpp_examples</a:t>
+            </a:r>
+          </a:p>
+          <a:p>
+            <a:pPr>
+              <a:spcAft>
+                <a:spcPts val="700"/>
+              </a:spcAft>
+              <a:defRPr sz="1100">
+                <a:solidFill>
+                  <a:srgbClr val="DFEDFF"/>
+                </a:solidFill>
+                <a:latin typeface="Noto Sans CJK KR"/>
+              </a:defRPr>
+            </a:pPr>
+            <a:r>
+              <a:t>source install/setup.bash</a:t>
+            </a:r>
+          </a:p>
+          <a:p>
+            <a:pPr>
+              <a:spcAft>
+                <a:spcPts val="700"/>
+              </a:spcAft>
+              <a:defRPr sz="1100">
+                <a:solidFill>
+                  <a:srgbClr val="DFEDFF"/>
+                </a:solidFill>
+                <a:latin typeface="Noto Sans CJK KR"/>
+              </a:defRPr>
+            </a:pPr>
+            <a:r>
+              <a:t>ros2 run agv_control counter_publisher</a:t>
+            </a:r>
+          </a:p>
+          <a:p>
+            <a:pPr>
+              <a:spcAft>
+                <a:spcPts val="700"/>
+              </a:spcAft>
+              <a:defRPr sz="1100">
+                <a:solidFill>
+                  <a:srgbClr val="DFEDFF"/>
+                </a:solidFill>
+                <a:latin typeface="Noto Sans CJK KR"/>
+              </a:defRPr>
+            </a:pPr>
+            <a:r>
+              <a:t># 새 터미널: ros2 run agv_control counter_monitor</a:t>
+            </a:r>
+          </a:p>
+          <a:p>
+            <a:pPr>
+              <a:spcAft>
+                <a:spcPts val="700"/>
+              </a:spcAft>
+              <a:defRPr sz="1100">
+                <a:solidFill>
+                  <a:srgbClr val="DFEDFF"/>
+                </a:solidFill>
+                <a:latin typeface="Noto Sans CJK KR"/>
+              </a:defRPr>
+            </a:pPr>
+            <a:r>
+              <a:t># C++ 비교: ros2 run agv_cpp_examples status_publisher</a:t>
+            </a:r>
+          </a:p>
+        </p:txBody>
+      </p:sp>
+      <p:sp>
+        <p:nvSpPr>
+          <p:cNvPr id="8" name="TextBox 7"/>
+          <p:cNvSpPr txBox="1"/>
+          <p:nvPr/>
+        </p:nvSpPr>
+        <p:spPr>
+          <a:xfrm>
+            <a:off x="685800" y="6089904"/>
+            <a:ext cx="10789920" cy="256032"/>
+          </a:xfrm>
+          <a:prstGeom prst="rect">
+            <a:avLst/>
+          </a:prstGeom>
+          <a:noFill/>
+        </p:spPr>
+        <p:txBody>
+          <a:bodyPr wrap="square" anchor="t">
+            <a:spAutoFit/>
+          </a:bodyPr>
+          <a:lstStyle/>
+          <a:p>
+            <a:pPr>
+              <a:spcAft>
+                <a:spcPts val="500"/>
+              </a:spcAft>
+              <a:defRPr sz="1000" b="0">
+                <a:solidFill>
+                  <a:srgbClr val="505C70"/>
+                </a:solidFill>
+                <a:latin typeface="Noto Sans CJK KR"/>
+              </a:defRPr>
+            </a:pPr>
+            <a:r>
+              <a:t>명령은 Block README의 순서와 동일합니다. 새 터미널에서도 ROS와 workspace를 source해야 합니다.</a:t>
+            </a:r>
+          </a:p>
+        </p:txBody>
+      </p:sp>
     </p:spTree>
   </p:cSld>
   <p:clrMapOvr>
@@ -4700,7 +5598,7 @@
               </a:defRPr>
             </a:pPr>
             <a:r>
-              <a:t>확인 기준과 다음 단계</a:t>
+              <a:t>명령어 동작과 설정 포인트</a:t>
             </a:r>
           </a:p>
         </p:txBody>
@@ -4778,7 +5676,7 @@
               </a:defRPr>
             </a:pPr>
             <a:r>
-              <a:t>통과 기준</a:t>
+              <a:t>이 명령이 실제로 하는 일</a:t>
             </a:r>
           </a:p>
         </p:txBody>
@@ -4817,7 +5715,536 @@
               </a:defRPr>
             </a:pPr>
             <a:r>
-              <a:t>• counter_monitor에 received /counter가 반복되면 publisher·subscriber·DDS 통신이 정상이다. 다음으로 M04에서 RViz Fixed Frame과 TF tree를 확인한다.</a:t>
+              <a:t>• source: 현재 터미널에 ROS 2 Jazzy와 workspace overlay를 등록한다.</a:t>
+            </a:r>
+          </a:p>
+          <a:p>
+            <a:pPr>
+              <a:spcAft>
+                <a:spcPts val="500"/>
+              </a:spcAft>
+              <a:defRPr sz="1500" b="0">
+                <a:solidFill>
+                  <a:srgbClr val="212B3D"/>
+                </a:solidFill>
+                <a:latin typeface="Noto Sans CJK KR"/>
+              </a:defRPr>
+            </a:pPr>
+            <a:r>
+              <a:t>• ros2 run: setup.py에 등록된 console script를 찾아 독립 노드로 실행한다.</a:t>
+            </a:r>
+          </a:p>
+          <a:p>
+            <a:pPr>
+              <a:spcAft>
+                <a:spcPts val="500"/>
+              </a:spcAft>
+              <a:defRPr sz="1500" b="0">
+                <a:solidFill>
+                  <a:srgbClr val="212B3D"/>
+                </a:solidFill>
+                <a:latin typeface="Noto Sans CJK KR"/>
+              </a:defRPr>
+            </a:pPr>
+            <a:r>
+              <a:t>• counter_publisher는 1초 timer·queue depth 10으로 /counter를 발행하며, 속도 명령은 -p linear_speed:=값으로 조절한다.</a:t>
+            </a:r>
+          </a:p>
+        </p:txBody>
+      </p:sp>
+      <p:sp>
+        <p:nvSpPr>
+          <p:cNvPr id="8" name="TextBox 7"/>
+          <p:cNvSpPr txBox="1"/>
+          <p:nvPr/>
+        </p:nvSpPr>
+        <p:spPr>
+          <a:xfrm>
+            <a:off x="731520" y="5440680"/>
+            <a:ext cx="10698480" cy="502920"/>
+          </a:xfrm>
+          <a:prstGeom prst="rect">
+            <a:avLst/>
+          </a:prstGeom>
+          <a:noFill/>
+        </p:spPr>
+        <p:txBody>
+          <a:bodyPr wrap="square" anchor="t">
+            <a:spAutoFit/>
+          </a:bodyPr>
+          <a:lstStyle/>
+          <a:p>
+            <a:pPr>
+              <a:spcAft>
+                <a:spcPts val="500"/>
+              </a:spcAft>
+              <a:defRPr sz="1200" b="0">
+                <a:solidFill>
+                  <a:srgbClr val="3F5373"/>
+                </a:solidFill>
+                <a:latin typeface="Noto Sans CJK KR"/>
+              </a:defRPr>
+            </a:pPr>
+            <a:r>
+              <a:t>수치·토픽·방향을 바꿀 때는 해당 Block의 Mxx README에서 구현 파일과 기대 결과를 함께 확인합니다.</a:t>
+            </a:r>
+          </a:p>
+        </p:txBody>
+      </p:sp>
+    </p:spTree>
+  </p:cSld>
+  <p:clrMapOvr>
+    <a:masterClrMapping/>
+  </p:clrMapOvr>
+</p:sld>
+</file>
+
+<file path=ppt/slides/slide7.xml><?xml version="1.0" encoding="utf-8"?>
+<p:sld xmlns:a="http://schemas.openxmlformats.org/drawingml/2006/main" xmlns:p="http://schemas.openxmlformats.org/presentationml/2006/main" xmlns:r="http://schemas.openxmlformats.org/officeDocument/2006/relationships">
+  <p:cSld>
+    <p:spTree>
+      <p:nvGrpSpPr>
+        <p:cNvPr id="1" name=""/>
+        <p:cNvGrpSpPr/>
+        <p:nvPr/>
+      </p:nvGrpSpPr>
+      <p:grpSpPr/>
+      <p:sp>
+        <p:nvSpPr>
+          <p:cNvPr id="2" name="Rectangle 1"/>
+          <p:cNvSpPr/>
+          <p:nvPr/>
+        </p:nvSpPr>
+        <p:spPr>
+          <a:xfrm>
+            <a:off x="0" y="0"/>
+            <a:ext cx="12191695" cy="749808"/>
+          </a:xfrm>
+          <a:prstGeom prst="rect">
+            <a:avLst/>
+          </a:prstGeom>
+          <a:solidFill>
+            <a:srgbClr val="173E6F"/>
+          </a:solidFill>
+          <a:ln>
+            <a:noFill/>
+          </a:ln>
+        </p:spPr>
+        <p:style>
+          <a:lnRef idx="1">
+            <a:schemeClr val="accent1"/>
+          </a:lnRef>
+          <a:fillRef idx="3">
+            <a:schemeClr val="accent1"/>
+          </a:fillRef>
+          <a:effectRef idx="2">
+            <a:schemeClr val="accent1"/>
+          </a:effectRef>
+          <a:fontRef idx="minor">
+            <a:schemeClr val="lt1"/>
+          </a:fontRef>
+        </p:style>
+        <p:txBody>
+          <a:bodyPr rtlCol="0" anchor="ctr"/>
+          <a:lstStyle/>
+          <a:p>
+            <a:pPr algn="ctr"/>
+          </a:p>
+        </p:txBody>
+      </p:sp>
+      <p:sp>
+        <p:nvSpPr>
+          <p:cNvPr id="3" name="TextBox 2"/>
+          <p:cNvSpPr txBox="1"/>
+          <p:nvPr/>
+        </p:nvSpPr>
+        <p:spPr>
+          <a:xfrm>
+            <a:off x="411480" y="137160"/>
+            <a:ext cx="8046720" cy="320040"/>
+          </a:xfrm>
+          <a:prstGeom prst="rect">
+            <a:avLst/>
+          </a:prstGeom>
+          <a:noFill/>
+        </p:spPr>
+        <p:txBody>
+          <a:bodyPr wrap="square" anchor="t">
+            <a:spAutoFit/>
+          </a:bodyPr>
+          <a:lstStyle/>
+          <a:p>
+            <a:pPr>
+              <a:spcAft>
+                <a:spcPts val="500"/>
+              </a:spcAft>
+              <a:defRPr sz="2500" b="1">
+                <a:solidFill>
+                  <a:srgbClr val="FFFFFF"/>
+                </a:solidFill>
+                <a:latin typeface="Noto Sans CJK KR"/>
+              </a:defRPr>
+            </a:pPr>
+            <a:r>
+              <a:t>Block A — ROS 2 기초</a:t>
+            </a:r>
+          </a:p>
+        </p:txBody>
+      </p:sp>
+      <p:sp>
+        <p:nvSpPr>
+          <p:cNvPr id="4" name="TextBox 3"/>
+          <p:cNvSpPr txBox="1"/>
+          <p:nvPr/>
+        </p:nvSpPr>
+        <p:spPr>
+          <a:xfrm>
+            <a:off x="8321040" y="182880"/>
+            <a:ext cx="3474720" cy="256032"/>
+          </a:xfrm>
+          <a:prstGeom prst="rect">
+            <a:avLst/>
+          </a:prstGeom>
+          <a:noFill/>
+        </p:spPr>
+        <p:txBody>
+          <a:bodyPr wrap="square" anchor="t">
+            <a:spAutoFit/>
+          </a:bodyPr>
+          <a:lstStyle/>
+          <a:p>
+            <a:pPr>
+              <a:spcAft>
+                <a:spcPts val="500"/>
+              </a:spcAft>
+              <a:defRPr sz="1000" b="0">
+                <a:solidFill>
+                  <a:srgbClr val="DCEAFC"/>
+                </a:solidFill>
+                <a:latin typeface="Noto Sans CJK KR"/>
+              </a:defRPr>
+            </a:pPr>
+            <a:r>
+              <a:t>실제 실행 결과</a:t>
+            </a:r>
+          </a:p>
+        </p:txBody>
+      </p:sp>
+      <p:sp>
+        <p:nvSpPr>
+          <p:cNvPr id="5" name="TextBox 4"/>
+          <p:cNvSpPr txBox="1"/>
+          <p:nvPr/>
+        </p:nvSpPr>
+        <p:spPr>
+          <a:xfrm>
+            <a:off x="411480" y="6556248"/>
+            <a:ext cx="11247120" cy="164592"/>
+          </a:xfrm>
+          <a:prstGeom prst="rect">
+            <a:avLst/>
+          </a:prstGeom>
+          <a:noFill/>
+        </p:spPr>
+        <p:txBody>
+          <a:bodyPr wrap="square" anchor="t">
+            <a:spAutoFit/>
+          </a:bodyPr>
+          <a:lstStyle/>
+          <a:p>
+            <a:pPr>
+              <a:spcAft>
+                <a:spcPts val="500"/>
+              </a:spcAft>
+              <a:defRPr sz="1000" b="0">
+                <a:solidFill>
+                  <a:srgbClr val="667080"/>
+                </a:solidFill>
+                <a:latin typeface="Noto Sans CJK KR"/>
+              </a:defRPr>
+            </a:pPr>
+            <a:r>
+              <a:t>ROS 2 + Gazebo AGV 실습 · 모든 텍스트 최소 10pt</a:t>
+            </a:r>
+          </a:p>
+        </p:txBody>
+      </p:sp>
+      <p:pic>
+        <p:nvPicPr>
+          <p:cNvPr id="6" name="Picture 5" descr="block_a_actual_terminal.png"/>
+          <p:cNvPicPr>
+            <a:picLocks noChangeAspect="1"/>
+          </p:cNvPicPr>
+          <p:nvPr/>
+        </p:nvPicPr>
+        <p:blipFill>
+          <a:blip r:embed="rId2"/>
+          <a:stretch>
+            <a:fillRect/>
+          </a:stretch>
+        </p:blipFill>
+        <p:spPr>
+          <a:xfrm>
+            <a:off x="411480" y="932688"/>
+            <a:ext cx="11365992" cy="5422392"/>
+          </a:xfrm>
+          <a:prstGeom prst="rect">
+            <a:avLst/>
+          </a:prstGeom>
+        </p:spPr>
+      </p:pic>
+    </p:spTree>
+  </p:cSld>
+  <p:clrMapOvr>
+    <a:masterClrMapping/>
+  </p:clrMapOvr>
+</p:sld>
+</file>
+
+<file path=ppt/slides/slide8.xml><?xml version="1.0" encoding="utf-8"?>
+<p:sld xmlns:a="http://schemas.openxmlformats.org/drawingml/2006/main" xmlns:p="http://schemas.openxmlformats.org/presentationml/2006/main" xmlns:r="http://schemas.openxmlformats.org/officeDocument/2006/relationships">
+  <p:cSld>
+    <p:spTree>
+      <p:nvGrpSpPr>
+        <p:cNvPr id="1" name=""/>
+        <p:cNvGrpSpPr/>
+        <p:nvPr/>
+      </p:nvGrpSpPr>
+      <p:grpSpPr/>
+      <p:sp>
+        <p:nvSpPr>
+          <p:cNvPr id="2" name="Rectangle 1"/>
+          <p:cNvSpPr/>
+          <p:nvPr/>
+        </p:nvSpPr>
+        <p:spPr>
+          <a:xfrm>
+            <a:off x="0" y="0"/>
+            <a:ext cx="12191695" cy="749808"/>
+          </a:xfrm>
+          <a:prstGeom prst="rect">
+            <a:avLst/>
+          </a:prstGeom>
+          <a:solidFill>
+            <a:srgbClr val="173E6F"/>
+          </a:solidFill>
+          <a:ln>
+            <a:noFill/>
+          </a:ln>
+        </p:spPr>
+        <p:style>
+          <a:lnRef idx="1">
+            <a:schemeClr val="accent1"/>
+          </a:lnRef>
+          <a:fillRef idx="3">
+            <a:schemeClr val="accent1"/>
+          </a:fillRef>
+          <a:effectRef idx="2">
+            <a:schemeClr val="accent1"/>
+          </a:effectRef>
+          <a:fontRef idx="minor">
+            <a:schemeClr val="lt1"/>
+          </a:fontRef>
+        </p:style>
+        <p:txBody>
+          <a:bodyPr rtlCol="0" anchor="ctr"/>
+          <a:lstStyle/>
+          <a:p>
+            <a:pPr algn="ctr"/>
+          </a:p>
+        </p:txBody>
+      </p:sp>
+      <p:sp>
+        <p:nvSpPr>
+          <p:cNvPr id="3" name="TextBox 2"/>
+          <p:cNvSpPr txBox="1"/>
+          <p:nvPr/>
+        </p:nvSpPr>
+        <p:spPr>
+          <a:xfrm>
+            <a:off x="411480" y="137160"/>
+            <a:ext cx="8046720" cy="320040"/>
+          </a:xfrm>
+          <a:prstGeom prst="rect">
+            <a:avLst/>
+          </a:prstGeom>
+          <a:noFill/>
+        </p:spPr>
+        <p:txBody>
+          <a:bodyPr wrap="square" anchor="t">
+            <a:spAutoFit/>
+          </a:bodyPr>
+          <a:lstStyle/>
+          <a:p>
+            <a:pPr>
+              <a:spcAft>
+                <a:spcPts val="500"/>
+              </a:spcAft>
+              <a:defRPr sz="2500" b="1">
+                <a:solidFill>
+                  <a:srgbClr val="FFFFFF"/>
+                </a:solidFill>
+                <a:latin typeface="Noto Sans CJK KR"/>
+              </a:defRPr>
+            </a:pPr>
+            <a:r>
+              <a:t>Block A — ROS 2 기초</a:t>
+            </a:r>
+          </a:p>
+        </p:txBody>
+      </p:sp>
+      <p:sp>
+        <p:nvSpPr>
+          <p:cNvPr id="4" name="TextBox 3"/>
+          <p:cNvSpPr txBox="1"/>
+          <p:nvPr/>
+        </p:nvSpPr>
+        <p:spPr>
+          <a:xfrm>
+            <a:off x="8321040" y="182880"/>
+            <a:ext cx="3474720" cy="256032"/>
+          </a:xfrm>
+          <a:prstGeom prst="rect">
+            <a:avLst/>
+          </a:prstGeom>
+          <a:noFill/>
+        </p:spPr>
+        <p:txBody>
+          <a:bodyPr wrap="square" anchor="t">
+            <a:spAutoFit/>
+          </a:bodyPr>
+          <a:lstStyle/>
+          <a:p>
+            <a:pPr>
+              <a:spcAft>
+                <a:spcPts val="500"/>
+              </a:spcAft>
+              <a:defRPr sz="1000" b="0">
+                <a:solidFill>
+                  <a:srgbClr val="DCEAFC"/>
+                </a:solidFill>
+                <a:latin typeface="Noto Sans CJK KR"/>
+              </a:defRPr>
+            </a:pPr>
+            <a:r>
+              <a:t>확인 기준과 다음 단계</a:t>
+            </a:r>
+          </a:p>
+        </p:txBody>
+      </p:sp>
+      <p:sp>
+        <p:nvSpPr>
+          <p:cNvPr id="5" name="TextBox 4"/>
+          <p:cNvSpPr txBox="1"/>
+          <p:nvPr/>
+        </p:nvSpPr>
+        <p:spPr>
+          <a:xfrm>
+            <a:off x="411480" y="6556248"/>
+            <a:ext cx="11247120" cy="164592"/>
+          </a:xfrm>
+          <a:prstGeom prst="rect">
+            <a:avLst/>
+          </a:prstGeom>
+          <a:noFill/>
+        </p:spPr>
+        <p:txBody>
+          <a:bodyPr wrap="square" anchor="t">
+            <a:spAutoFit/>
+          </a:bodyPr>
+          <a:lstStyle/>
+          <a:p>
+            <a:pPr>
+              <a:spcAft>
+                <a:spcPts val="500"/>
+              </a:spcAft>
+              <a:defRPr sz="1000" b="0">
+                <a:solidFill>
+                  <a:srgbClr val="667080"/>
+                </a:solidFill>
+                <a:latin typeface="Noto Sans CJK KR"/>
+              </a:defRPr>
+            </a:pPr>
+            <a:r>
+              <a:t>ROS 2 + Gazebo AGV 실습 · 모든 텍스트 최소 10pt</a:t>
+            </a:r>
+          </a:p>
+        </p:txBody>
+      </p:sp>
+      <p:sp>
+        <p:nvSpPr>
+          <p:cNvPr id="6" name="TextBox 5"/>
+          <p:cNvSpPr txBox="1"/>
+          <p:nvPr/>
+        </p:nvSpPr>
+        <p:spPr>
+          <a:xfrm>
+            <a:off x="594360" y="960120"/>
+            <a:ext cx="10972800" cy="411480"/>
+          </a:xfrm>
+          <a:prstGeom prst="rect">
+            <a:avLst/>
+          </a:prstGeom>
+          <a:noFill/>
+        </p:spPr>
+        <p:txBody>
+          <a:bodyPr wrap="square" anchor="t">
+            <a:spAutoFit/>
+          </a:bodyPr>
+          <a:lstStyle/>
+          <a:p>
+            <a:pPr>
+              <a:spcAft>
+                <a:spcPts val="500"/>
+              </a:spcAft>
+              <a:defRPr sz="2100" b="1">
+                <a:solidFill>
+                  <a:srgbClr val="173E6F"/>
+                </a:solidFill>
+                <a:latin typeface="Noto Sans CJK KR"/>
+              </a:defRPr>
+            </a:pPr>
+            <a:r>
+              <a:t>통과 기준</a:t>
+            </a:r>
+          </a:p>
+        </p:txBody>
+      </p:sp>
+      <p:sp>
+        <p:nvSpPr>
+          <p:cNvPr id="7" name="TextBox 6"/>
+          <p:cNvSpPr txBox="1"/>
+          <p:nvPr/>
+        </p:nvSpPr>
+        <p:spPr>
+          <a:xfrm>
+            <a:off x="731520" y="1508760"/>
+            <a:ext cx="10698480" cy="4480560"/>
+          </a:xfrm>
+          <a:prstGeom prst="rect">
+            <a:avLst/>
+          </a:prstGeom>
+          <a:noFill/>
+        </p:spPr>
+        <p:txBody>
+          <a:bodyPr wrap="square" anchor="t">
+            <a:spAutoFit/>
+          </a:bodyPr>
+          <a:lstStyle/>
+          <a:p>
+            <a:pPr>
+              <a:spcAft>
+                <a:spcPts val="500"/>
+              </a:spcAft>
+              <a:defRPr sz="1500" b="0">
+                <a:solidFill>
+                  <a:srgbClr val="212B3D"/>
+                </a:solidFill>
+                <a:latin typeface="Noto Sans CJK KR"/>
+              </a:defRPr>
+            </a:pPr>
+            <a:r>
+              <a:t>• C++ publisher의 /cpp_status와 Python counter_monitor의 /counter가 각각 수신되면 두 언어의 ROS 2 node 구조가 정상이다. 다음으로 M04에서 RViz Fixed Frame과 TF tree를 확인한다.</a:t>
             </a:r>
           </a:p>
           <a:p>

</xml_diff>